<commit_message>
Updated team details: CodeCatalyst (Reg No: EV896e63aa615213), members & PPT slide
</commit_message>
<xml_diff>
--- a/ScopeGuard_SS26_AIH_Deck.pptx
+++ b/ScopeGuard_SS26_AIH_Deck.pptx
@@ -1250,6 +1250,10 @@
           </a:solidFill>
           <a:ln/>
         </p:spPr>
+        <p:txBody>
+          <a:bodyPr/>
+          <a:p/>
+        </p:txBody>
       </p:sp>
       <p:sp>
         <p:nvSpPr>
@@ -1275,6 +1279,10 @@
             <a:prstDash val="solid"/>
           </a:ln>
         </p:spPr>
+        <p:txBody>
+          <a:bodyPr/>
+          <a:p/>
+        </p:txBody>
       </p:sp>
       <p:sp>
         <p:nvSpPr>
@@ -1356,6 +1364,10 @@
             <a:prstDash val="solid"/>
           </a:ln>
         </p:spPr>
+        <p:txBody>
+          <a:bodyPr/>
+          <a:p/>
+        </p:txBody>
       </p:sp>
       <p:sp>
         <p:nvSpPr>
@@ -1476,6 +1488,10 @@
             <a:prstDash val="solid"/>
           </a:ln>
         </p:spPr>
+        <p:txBody>
+          <a:bodyPr/>
+          <a:p/>
+        </p:txBody>
       </p:sp>
       <p:sp>
         <p:nvSpPr>
@@ -1581,6 +1597,10 @@
             <a:prstDash val="solid"/>
           </a:ln>
         </p:spPr>
+        <p:txBody>
+          <a:bodyPr/>
+          <a:p/>
+        </p:txBody>
       </p:sp>
       <p:sp>
         <p:nvSpPr>
@@ -1642,21 +1662,24 @@
           <a:bodyPr wrap="square" rtlCol="0" anchor="ctr"/>
           <a:lstStyle/>
           <a:p>
-            <a:pPr indent="0" marL="0">
-              <a:buNone/>
-            </a:pPr>
-            <a:r>
-              <a:rPr lang="en-US" sz="1500" b="1" dirty="0">
-                <a:solidFill>
-                  <a:srgbClr val="1F1F1F"/>
-                </a:solidFill>
-                <a:latin typeface="Cambria" pitchFamily="34" charset="0"/>
-                <a:ea typeface="Cambria" pitchFamily="34" charset="-122"/>
-                <a:cs typeface="Cambria" pitchFamily="34" charset="-120"/>
-              </a:rPr>
+            <a:r>
               <a:t>TEAM DETAILS</a:t>
             </a:r>
-            <a:endParaRPr lang="en-US" sz="1500" dirty="0"/>
+          </a:p>
+          <a:p>
+            <a:r>
+              <a:t>Team Name: CodeCatalyst | Reg No: EV896e63aa615213</a:t>
+            </a:r>
+          </a:p>
+          <a:p>
+            <a:r>
+              <a:t>Members: Dilshan Pal Singh (Lead) | Sudhanshu Bhat | Ansul Mishra</a:t>
+            </a:r>
+          </a:p>
+          <a:p>
+            <a:r>
+              <a:t>Contact: dilshanpal27singh@gmail.com (+91-8899965771)</a:t>
+            </a:r>
           </a:p>
         </p:txBody>
       </p:sp>
@@ -1681,63 +1704,24 @@
           <a:bodyPr wrap="square" rtlCol="0" anchor="ctr"/>
           <a:lstStyle/>
           <a:p>
-            <a:pPr indent="0" marL="0">
-              <a:buNone/>
-            </a:pPr>
-            <a:r>
-              <a:rPr lang="en-US" sz="1250" b="1" dirty="0">
-                <a:solidFill>
-                  <a:srgbClr val="1F1F1F"/>
-                </a:solidFill>
-                <a:latin typeface="Calibri" pitchFamily="34" charset="0"/>
-                <a:ea typeface="Calibri" pitchFamily="34" charset="-122"/>
-                <a:cs typeface="Calibri" pitchFamily="34" charset="-120"/>
-              </a:rPr>
-              <a:t>Team Name: </a:t>
-            </a:r>
-            <a:pPr indent="0" marL="0">
-              <a:buNone/>
-            </a:pPr>
-            <a:r>
-              <a:rPr lang="en-US" sz="1250" dirty="0">
-                <a:solidFill>
-                  <a:srgbClr val="1F1F1F"/>
-                </a:solidFill>
-                <a:latin typeface="Calibri" pitchFamily="34" charset="0"/>
-                <a:ea typeface="Calibri" pitchFamily="34" charset="-122"/>
-                <a:cs typeface="Calibri" pitchFamily="34" charset="-120"/>
-              </a:rPr>
-              <a:t>[Team Name]   </a:t>
-            </a:r>
-            <a:pPr indent="0" marL="0">
-              <a:buNone/>
-            </a:pPr>
-            <a:r>
-              <a:rPr lang="en-US" sz="1250" b="1" dirty="0">
-                <a:solidFill>
-                  <a:srgbClr val="1F1F1F"/>
-                </a:solidFill>
-                <a:latin typeface="Calibri" pitchFamily="34" charset="0"/>
-                <a:ea typeface="Calibri" pitchFamily="34" charset="-122"/>
-                <a:cs typeface="Calibri" pitchFamily="34" charset="-120"/>
-              </a:rPr>
-              <a:t>College / Institution: </a:t>
-            </a:r>
-            <a:pPr indent="0" marL="0">
-              <a:buNone/>
-            </a:pPr>
-            <a:r>
-              <a:rPr lang="en-US" sz="1250" dirty="0">
-                <a:solidFill>
-                  <a:srgbClr val="1F1F1F"/>
-                </a:solidFill>
-                <a:latin typeface="Calibri" pitchFamily="34" charset="0"/>
-                <a:ea typeface="Calibri" pitchFamily="34" charset="-122"/>
-                <a:cs typeface="Calibri" pitchFamily="34" charset="-120"/>
-              </a:rPr>
-              <a:t>[College Name]</a:t>
-            </a:r>
-            <a:endParaRPr lang="en-US" sz="1250" dirty="0"/>
+            <a:r>
+              <a:t>TEAM DETAILS</a:t>
+            </a:r>
+          </a:p>
+          <a:p>
+            <a:r>
+              <a:t>Team Name: CodeCatalyst | Reg No: EV896e63aa615213</a:t>
+            </a:r>
+          </a:p>
+          <a:p>
+            <a:r>
+              <a:t>Members: Dilshan Pal Singh (Lead) | Sudhanshu Bhat | Ansul Mishra</a:t>
+            </a:r>
+          </a:p>
+          <a:p>
+            <a:r>
+              <a:t>Contact: dilshanpal27singh@gmail.com (+91-8899965771)</a:t>
+            </a:r>
           </a:p>
         </p:txBody>
       </p:sp>

</xml_diff>